<commit_message>
Switch decks to white background with restrained coral accent
Co-Authored-By: Claude Sonnet 5.5 <noreply@anthropic.com>
Claude-Session: https://claude.ai/code/session_01EAJx54yEDWUst2AHK2BTn1
</commit_message>
<xml_diff>
--- a/guruguru/guruguru_game_design.pptx
+++ b/guruguru/guruguru_game_design.pptx
@@ -3090,7 +3090,7 @@
     <p:bg>
       <p:bgPr>
         <a:solidFill>
-          <a:srgbClr val="FFEEE4"/>
+          <a:srgbClr val="FFFFFF"/>
         </a:solidFill>
         <a:effectLst/>
       </p:bgPr>
@@ -3110,8 +3110,8 @@
         </p:nvSpPr>
         <p:spPr>
           <a:xfrm>
-            <a:off x="0" y="6675120"/>
-            <a:ext cx="12191695" cy="182880"/>
+            <a:off x="0" y="6766560"/>
+            <a:ext cx="12191695" cy="91440"/>
           </a:xfrm>
           <a:prstGeom prst="rect">
             <a:avLst/>
@@ -3197,7 +3197,7 @@
             <a:r>
               <a:rPr sz="2000" b="1">
                 <a:solidFill>
-                  <a:srgbClr val="F06142"/>
+                  <a:srgbClr val="333333"/>
                 </a:solidFill>
                 <a:latin typeface="Yu Gothic"/>
               </a:rPr>
@@ -3256,7 +3256,7 @@
             <a:avLst/>
           </a:prstGeom>
           <a:solidFill>
-            <a:srgbClr val="FFFFFF"/>
+            <a:srgbClr val="F4F4F4"/>
           </a:solidFill>
           <a:ln>
             <a:noFill/>
@@ -3297,7 +3297,7 @@
             <a:r>
               <a:rPr sz="1600" b="1">
                 <a:solidFill>
-                  <a:srgbClr val="F06142"/>
+                  <a:srgbClr val="333333"/>
                 </a:solidFill>
                 <a:latin typeface="Yu Gothic"/>
               </a:rPr>
@@ -3376,7 +3376,7 @@
             <a:avLst/>
           </a:prstGeom>
           <a:solidFill>
-            <a:srgbClr val="FFFFFF"/>
+            <a:srgbClr val="F4F4F4"/>
           </a:solidFill>
           <a:ln>
             <a:noFill/>
@@ -3417,7 +3417,7 @@
             <a:r>
               <a:rPr sz="1600" b="1">
                 <a:solidFill>
-                  <a:srgbClr val="F06142"/>
+                  <a:srgbClr val="333333"/>
                 </a:solidFill>
                 <a:latin typeface="Yu Gothic"/>
               </a:rPr>
@@ -3496,7 +3496,7 @@
             <a:avLst/>
           </a:prstGeom>
           <a:solidFill>
-            <a:srgbClr val="FFFFFF"/>
+            <a:srgbClr val="F4F4F4"/>
           </a:solidFill>
           <a:ln>
             <a:noFill/>
@@ -3537,7 +3537,7 @@
             <a:r>
               <a:rPr sz="1600" b="1">
                 <a:solidFill>
-                  <a:srgbClr val="F06142"/>
+                  <a:srgbClr val="333333"/>
                 </a:solidFill>
                 <a:latin typeface="Yu Gothic"/>
               </a:rPr>
@@ -3627,7 +3627,7 @@
             <a:r>
               <a:rPr sz="1600" b="1">
                 <a:solidFill>
-                  <a:srgbClr val="F06142"/>
+                  <a:srgbClr val="333333"/>
                 </a:solidFill>
                 <a:latin typeface="Yu Gothic"/>
               </a:rPr>
@@ -3690,7 +3690,7 @@
             <a:avLst/>
           </a:prstGeom>
           <a:solidFill>
-            <a:srgbClr val="FFFFFF"/>
+            <a:srgbClr val="F4F4F4"/>
           </a:solidFill>
           <a:ln>
             <a:noFill/>
@@ -3768,7 +3768,7 @@
             <a:avLst/>
           </a:prstGeom>
           <a:solidFill>
-            <a:srgbClr val="FFFFFF"/>
+            <a:srgbClr val="F4F4F4"/>
           </a:solidFill>
           <a:ln>
             <a:noFill/>
@@ -3846,7 +3846,7 @@
             <a:avLst/>
           </a:prstGeom>
           <a:solidFill>
-            <a:srgbClr val="FFFFFF"/>
+            <a:srgbClr val="F4F4F4"/>
           </a:solidFill>
           <a:ln>
             <a:noFill/>
@@ -3924,7 +3924,7 @@
             <a:avLst/>
           </a:prstGeom>
           <a:solidFill>
-            <a:srgbClr val="FFFFFF"/>
+            <a:srgbClr val="F4F4F4"/>
           </a:solidFill>
           <a:ln>
             <a:noFill/>
@@ -3963,7 +3963,7 @@
             <a:avLst/>
           </a:prstGeom>
           <a:solidFill>
-            <a:srgbClr val="FFE0D0"/>
+            <a:srgbClr val="F9ECE6"/>
           </a:solidFill>
           <a:ln>
             <a:noFill/>
@@ -3978,7 +3978,7 @@
             <a:r>
               <a:rPr sz="1500" b="1">
                 <a:solidFill>
-                  <a:srgbClr val="F06142"/>
+                  <a:srgbClr val="333333"/>
                 </a:solidFill>
                 <a:latin typeface="Yu Gothic"/>
               </a:rPr>
@@ -4017,7 +4017,7 @@
     <p:bg>
       <p:bgPr>
         <a:solidFill>
-          <a:srgbClr val="FFEEE4"/>
+          <a:srgbClr val="FFFFFF"/>
         </a:solidFill>
         <a:effectLst/>
       </p:bgPr>
@@ -4037,8 +4037,8 @@
         </p:nvSpPr>
         <p:spPr>
           <a:xfrm>
-            <a:off x="0" y="6675120"/>
-            <a:ext cx="12191695" cy="182880"/>
+            <a:off x="0" y="6766560"/>
+            <a:ext cx="12191695" cy="91440"/>
           </a:xfrm>
           <a:prstGeom prst="rect">
             <a:avLst/>
@@ -4124,7 +4124,7 @@
             <a:r>
               <a:rPr sz="2000" b="1">
                 <a:solidFill>
-                  <a:srgbClr val="F06142"/>
+                  <a:srgbClr val="333333"/>
                 </a:solidFill>
                 <a:latin typeface="Yu Gothic"/>
               </a:rPr>
@@ -4183,7 +4183,7 @@
             <a:avLst/>
           </a:prstGeom>
           <a:solidFill>
-            <a:srgbClr val="FFE0D0"/>
+            <a:srgbClr val="F9ECE6"/>
           </a:solidFill>
           <a:ln>
             <a:noFill/>
@@ -4221,7 +4221,7 @@
             <a:avLst/>
           </a:prstGeom>
           <a:solidFill>
-            <a:srgbClr val="FFFFFF"/>
+            <a:srgbClr val="F4F4F4"/>
           </a:solidFill>
           <a:ln>
             <a:noFill/>
@@ -4283,7 +4283,7 @@
             <a:r>
               <a:rPr sz="1300" b="1">
                 <a:solidFill>
-                  <a:srgbClr val="F06142"/>
+                  <a:srgbClr val="333333"/>
                 </a:solidFill>
                 <a:latin typeface="Yu Gothic"/>
               </a:rPr>
@@ -4307,7 +4307,7 @@
             <a:avLst/>
           </a:prstGeom>
           <a:solidFill>
-            <a:srgbClr val="FFE0D0"/>
+            <a:srgbClr val="F9ECE6"/>
           </a:solidFill>
           <a:ln>
             <a:noFill/>
@@ -4345,7 +4345,7 @@
             <a:avLst/>
           </a:prstGeom>
           <a:solidFill>
-            <a:srgbClr val="FFFFFF"/>
+            <a:srgbClr val="F4F4F4"/>
           </a:solidFill>
           <a:ln>
             <a:noFill/>
@@ -4407,7 +4407,7 @@
             <a:r>
               <a:rPr sz="1300" b="1">
                 <a:solidFill>
-                  <a:srgbClr val="F06142"/>
+                  <a:srgbClr val="333333"/>
                 </a:solidFill>
                 <a:latin typeface="Yu Gothic"/>
               </a:rPr>
@@ -4431,7 +4431,7 @@
             <a:avLst/>
           </a:prstGeom>
           <a:solidFill>
-            <a:srgbClr val="FFE0D0"/>
+            <a:srgbClr val="F9ECE6"/>
           </a:solidFill>
           <a:ln>
             <a:noFill/>
@@ -4469,7 +4469,7 @@
             <a:avLst/>
           </a:prstGeom>
           <a:solidFill>
-            <a:srgbClr val="FFFFFF"/>
+            <a:srgbClr val="F4F4F4"/>
           </a:solidFill>
           <a:ln>
             <a:noFill/>
@@ -4531,7 +4531,7 @@
             <a:r>
               <a:rPr sz="1300" b="1">
                 <a:solidFill>
-                  <a:srgbClr val="F06142"/>
+                  <a:srgbClr val="333333"/>
                 </a:solidFill>
                 <a:latin typeface="Yu Gothic"/>
               </a:rPr>
@@ -4593,7 +4593,7 @@
             <a:avLst/>
           </a:prstGeom>
           <a:solidFill>
-            <a:srgbClr val="FFFFFF"/>
+            <a:srgbClr val="F4F4F4"/>
           </a:solidFill>
           <a:ln>
             <a:noFill/>
@@ -4655,7 +4655,7 @@
             <a:r>
               <a:rPr sz="1300" b="1">
                 <a:solidFill>
-                  <a:srgbClr val="F06142"/>
+                  <a:srgbClr val="333333"/>
                 </a:solidFill>
                 <a:latin typeface="Yu Gothic"/>
               </a:rPr>
@@ -4679,7 +4679,7 @@
             <a:avLst/>
           </a:prstGeom>
           <a:solidFill>
-            <a:srgbClr val="FFE0D0"/>
+            <a:srgbClr val="F9ECE6"/>
           </a:solidFill>
           <a:ln>
             <a:noFill/>
@@ -4717,7 +4717,7 @@
             <a:avLst/>
           </a:prstGeom>
           <a:solidFill>
-            <a:srgbClr val="FFFFFF"/>
+            <a:srgbClr val="F4F4F4"/>
           </a:solidFill>
           <a:ln>
             <a:noFill/>
@@ -4779,7 +4779,7 @@
             <a:r>
               <a:rPr sz="1300" b="1">
                 <a:solidFill>
-                  <a:srgbClr val="F06142"/>
+                  <a:srgbClr val="333333"/>
                 </a:solidFill>
                 <a:latin typeface="Yu Gothic"/>
               </a:rPr>
@@ -4803,7 +4803,7 @@
             <a:avLst/>
           </a:prstGeom>
           <a:solidFill>
-            <a:srgbClr val="FFFFFF"/>
+            <a:srgbClr val="F4F4F4"/>
           </a:solidFill>
           <a:ln>
             <a:noFill/>
@@ -4844,7 +4844,7 @@
             <a:r>
               <a:rPr sz="1600" b="1">
                 <a:solidFill>
-                  <a:srgbClr val="F06142"/>
+                  <a:srgbClr val="333333"/>
                 </a:solidFill>
                 <a:latin typeface="Yu Gothic"/>
               </a:rPr>
@@ -4955,7 +4955,7 @@
             <a:avLst/>
           </a:prstGeom>
           <a:solidFill>
-            <a:srgbClr val="FFFFFF"/>
+            <a:srgbClr val="F4F4F4"/>
           </a:solidFill>
           <a:ln>
             <a:noFill/>
@@ -4996,7 +4996,7 @@
             <a:r>
               <a:rPr sz="1600" b="1">
                 <a:solidFill>
-                  <a:srgbClr val="F06142"/>
+                  <a:srgbClr val="333333"/>
                 </a:solidFill>
                 <a:latin typeface="Yu Gothic"/>
               </a:rPr>
@@ -5106,7 +5106,7 @@
     <p:bg>
       <p:bgPr>
         <a:solidFill>
-          <a:srgbClr val="FFEEE4"/>
+          <a:srgbClr val="FFFFFF"/>
         </a:solidFill>
         <a:effectLst/>
       </p:bgPr>
@@ -5126,8 +5126,8 @@
         </p:nvSpPr>
         <p:spPr>
           <a:xfrm>
-            <a:off x="0" y="6675120"/>
-            <a:ext cx="12191695" cy="182880"/>
+            <a:off x="0" y="6766560"/>
+            <a:ext cx="12191695" cy="91440"/>
           </a:xfrm>
           <a:prstGeom prst="rect">
             <a:avLst/>
@@ -5213,7 +5213,7 @@
             <a:r>
               <a:rPr sz="2000" b="1">
                 <a:solidFill>
-                  <a:srgbClr val="F06142"/>
+                  <a:srgbClr val="333333"/>
                 </a:solidFill>
                 <a:latin typeface="Yu Gothic"/>
               </a:rPr>
@@ -5272,7 +5272,7 @@
             <a:avLst/>
           </a:prstGeom>
           <a:solidFill>
-            <a:srgbClr val="F06142"/>
+            <a:srgbClr val="333333"/>
           </a:solidFill>
           <a:ln>
             <a:noFill/>
@@ -5311,7 +5311,7 @@
             <a:avLst/>
           </a:prstGeom>
           <a:solidFill>
-            <a:srgbClr val="F06142"/>
+            <a:srgbClr val="333333"/>
           </a:solidFill>
           <a:ln>
             <a:noFill/>
@@ -5350,7 +5350,7 @@
             <a:avLst/>
           </a:prstGeom>
           <a:solidFill>
-            <a:srgbClr val="F06142"/>
+            <a:srgbClr val="333333"/>
           </a:solidFill>
           <a:ln>
             <a:noFill/>
@@ -5389,7 +5389,7 @@
             <a:avLst/>
           </a:prstGeom>
           <a:solidFill>
-            <a:srgbClr val="FFE0D0"/>
+            <a:srgbClr val="F9ECE6"/>
           </a:solidFill>
           <a:ln>
             <a:noFill/>
@@ -5404,7 +5404,7 @@
             <a:r>
               <a:rPr sz="1250" b="1">
                 <a:solidFill>
-                  <a:srgbClr val="F06142"/>
+                  <a:srgbClr val="333333"/>
                 </a:solidFill>
                 <a:latin typeface="Yu Gothic"/>
               </a:rPr>
@@ -5428,7 +5428,7 @@
             <a:avLst/>
           </a:prstGeom>
           <a:solidFill>
-            <a:srgbClr val="FFFFFF"/>
+            <a:srgbClr val="F4F4F4"/>
           </a:solidFill>
           <a:ln>
             <a:noFill/>
@@ -5467,7 +5467,7 @@
             <a:avLst/>
           </a:prstGeom>
           <a:solidFill>
-            <a:srgbClr val="FFFFFF"/>
+            <a:srgbClr val="F4F4F4"/>
           </a:solidFill>
           <a:ln>
             <a:noFill/>
@@ -5506,7 +5506,7 @@
             <a:avLst/>
           </a:prstGeom>
           <a:solidFill>
-            <a:srgbClr val="FFE0D0"/>
+            <a:srgbClr val="F9ECE6"/>
           </a:solidFill>
           <a:ln>
             <a:noFill/>
@@ -5521,7 +5521,7 @@
             <a:r>
               <a:rPr sz="1250" b="1">
                 <a:solidFill>
-                  <a:srgbClr val="F06142"/>
+                  <a:srgbClr val="333333"/>
                 </a:solidFill>
                 <a:latin typeface="Yu Gothic"/>
               </a:rPr>
@@ -5545,7 +5545,7 @@
             <a:avLst/>
           </a:prstGeom>
           <a:solidFill>
-            <a:srgbClr val="FFFFFF"/>
+            <a:srgbClr val="F4F4F4"/>
           </a:solidFill>
           <a:ln>
             <a:noFill/>
@@ -5584,7 +5584,7 @@
             <a:avLst/>
           </a:prstGeom>
           <a:solidFill>
-            <a:srgbClr val="FFFFFF"/>
+            <a:srgbClr val="F4F4F4"/>
           </a:solidFill>
           <a:ln>
             <a:noFill/>
@@ -5623,7 +5623,7 @@
             <a:avLst/>
           </a:prstGeom>
           <a:solidFill>
-            <a:srgbClr val="FFE0D0"/>
+            <a:srgbClr val="F9ECE6"/>
           </a:solidFill>
           <a:ln>
             <a:noFill/>
@@ -5638,7 +5638,7 @@
             <a:r>
               <a:rPr sz="1250" b="1">
                 <a:solidFill>
-                  <a:srgbClr val="F06142"/>
+                  <a:srgbClr val="333333"/>
                 </a:solidFill>
                 <a:latin typeface="Yu Gothic"/>
               </a:rPr>
@@ -5662,7 +5662,7 @@
             <a:avLst/>
           </a:prstGeom>
           <a:solidFill>
-            <a:srgbClr val="FFFFFF"/>
+            <a:srgbClr val="F4F4F4"/>
           </a:solidFill>
           <a:ln>
             <a:noFill/>
@@ -5701,7 +5701,7 @@
             <a:avLst/>
           </a:prstGeom>
           <a:solidFill>
-            <a:srgbClr val="FFFFFF"/>
+            <a:srgbClr val="F4F4F4"/>
           </a:solidFill>
           <a:ln>
             <a:noFill/>
@@ -5740,7 +5740,7 @@
             <a:avLst/>
           </a:prstGeom>
           <a:solidFill>
-            <a:srgbClr val="FFE0D0"/>
+            <a:srgbClr val="F9ECE6"/>
           </a:solidFill>
           <a:ln>
             <a:noFill/>
@@ -5755,7 +5755,7 @@
             <a:r>
               <a:rPr sz="1250" b="1">
                 <a:solidFill>
-                  <a:srgbClr val="F06142"/>
+                  <a:srgbClr val="333333"/>
                 </a:solidFill>
                 <a:latin typeface="Yu Gothic"/>
               </a:rPr>
@@ -5779,7 +5779,7 @@
             <a:avLst/>
           </a:prstGeom>
           <a:solidFill>
-            <a:srgbClr val="FFFFFF"/>
+            <a:srgbClr val="F4F4F4"/>
           </a:solidFill>
           <a:ln>
             <a:noFill/>
@@ -5818,7 +5818,7 @@
             <a:avLst/>
           </a:prstGeom>
           <a:solidFill>
-            <a:srgbClr val="FFFFFF"/>
+            <a:srgbClr val="F4F4F4"/>
           </a:solidFill>
           <a:ln>
             <a:noFill/>
@@ -5857,7 +5857,7 @@
             <a:avLst/>
           </a:prstGeom>
           <a:solidFill>
-            <a:srgbClr val="FFE0D0"/>
+            <a:srgbClr val="F9ECE6"/>
           </a:solidFill>
           <a:ln>
             <a:noFill/>
@@ -5872,7 +5872,7 @@
             <a:r>
               <a:rPr sz="1250" b="1">
                 <a:solidFill>
-                  <a:srgbClr val="F06142"/>
+                  <a:srgbClr val="333333"/>
                 </a:solidFill>
                 <a:latin typeface="Yu Gothic"/>
               </a:rPr>
@@ -5896,7 +5896,7 @@
             <a:avLst/>
           </a:prstGeom>
           <a:solidFill>
-            <a:srgbClr val="FFFFFF"/>
+            <a:srgbClr val="F4F4F4"/>
           </a:solidFill>
           <a:ln>
             <a:noFill/>
@@ -5935,7 +5935,7 @@
             <a:avLst/>
           </a:prstGeom>
           <a:solidFill>
-            <a:srgbClr val="FFFFFF"/>
+            <a:srgbClr val="F4F4F4"/>
           </a:solidFill>
           <a:ln>
             <a:noFill/>
@@ -5974,7 +5974,7 @@
             <a:avLst/>
           </a:prstGeom>
           <a:solidFill>
-            <a:srgbClr val="FFE0D0"/>
+            <a:srgbClr val="F9ECE6"/>
           </a:solidFill>
           <a:ln>
             <a:noFill/>
@@ -6015,7 +6015,7 @@
             <a:r>
               <a:rPr sz="1600" b="1">
                 <a:solidFill>
-                  <a:srgbClr val="F06142"/>
+                  <a:srgbClr val="333333"/>
                 </a:solidFill>
                 <a:latin typeface="Yu Gothic"/>
               </a:rPr>
@@ -6093,7 +6093,7 @@
     <p:bg>
       <p:bgPr>
         <a:solidFill>
-          <a:srgbClr val="FFEEE4"/>
+          <a:srgbClr val="FFFFFF"/>
         </a:solidFill>
         <a:effectLst/>
       </p:bgPr>
@@ -6113,8 +6113,8 @@
         </p:nvSpPr>
         <p:spPr>
           <a:xfrm>
-            <a:off x="0" y="6675120"/>
-            <a:ext cx="12191695" cy="182880"/>
+            <a:off x="0" y="6766560"/>
+            <a:ext cx="12191695" cy="91440"/>
           </a:xfrm>
           <a:prstGeom prst="rect">
             <a:avLst/>
@@ -6200,7 +6200,7 @@
             <a:r>
               <a:rPr sz="2000" b="1">
                 <a:solidFill>
-                  <a:srgbClr val="F06142"/>
+                  <a:srgbClr val="333333"/>
                 </a:solidFill>
                 <a:latin typeface="Yu Gothic"/>
               </a:rPr>
@@ -6259,7 +6259,7 @@
             <a:avLst/>
           </a:prstGeom>
           <a:solidFill>
-            <a:srgbClr val="F06142"/>
+            <a:srgbClr val="333333"/>
           </a:solidFill>
           <a:ln>
             <a:noFill/>
@@ -6298,7 +6298,7 @@
             <a:avLst/>
           </a:prstGeom>
           <a:solidFill>
-            <a:srgbClr val="F06142"/>
+            <a:srgbClr val="333333"/>
           </a:solidFill>
           <a:ln>
             <a:noFill/>
@@ -6337,7 +6337,7 @@
             <a:avLst/>
           </a:prstGeom>
           <a:solidFill>
-            <a:srgbClr val="F06142"/>
+            <a:srgbClr val="333333"/>
           </a:solidFill>
           <a:ln>
             <a:noFill/>
@@ -6376,7 +6376,7 @@
             <a:avLst/>
           </a:prstGeom>
           <a:solidFill>
-            <a:srgbClr val="FFE0D0"/>
+            <a:srgbClr val="F9ECE6"/>
           </a:solidFill>
           <a:ln>
             <a:noFill/>
@@ -6391,7 +6391,7 @@
             <a:r>
               <a:rPr sz="1300" b="1">
                 <a:solidFill>
-                  <a:srgbClr val="F06142"/>
+                  <a:srgbClr val="333333"/>
                 </a:solidFill>
                 <a:latin typeface="Yu Gothic"/>
               </a:rPr>
@@ -6415,7 +6415,7 @@
             <a:avLst/>
           </a:prstGeom>
           <a:solidFill>
-            <a:srgbClr val="FFFFFF"/>
+            <a:srgbClr val="F4F4F4"/>
           </a:solidFill>
           <a:ln>
             <a:noFill/>
@@ -6454,7 +6454,7 @@
             <a:avLst/>
           </a:prstGeom>
           <a:solidFill>
-            <a:srgbClr val="FFFFFF"/>
+            <a:srgbClr val="F4F4F4"/>
           </a:solidFill>
           <a:ln>
             <a:noFill/>
@@ -6493,7 +6493,7 @@
             <a:avLst/>
           </a:prstGeom>
           <a:solidFill>
-            <a:srgbClr val="FFE0D0"/>
+            <a:srgbClr val="F9ECE6"/>
           </a:solidFill>
           <a:ln>
             <a:noFill/>
@@ -6508,7 +6508,7 @@
             <a:r>
               <a:rPr sz="1300" b="1">
                 <a:solidFill>
-                  <a:srgbClr val="F06142"/>
+                  <a:srgbClr val="333333"/>
                 </a:solidFill>
                 <a:latin typeface="Yu Gothic"/>
               </a:rPr>
@@ -6532,7 +6532,7 @@
             <a:avLst/>
           </a:prstGeom>
           <a:solidFill>
-            <a:srgbClr val="FFFFFF"/>
+            <a:srgbClr val="F4F4F4"/>
           </a:solidFill>
           <a:ln>
             <a:noFill/>
@@ -6571,7 +6571,7 @@
             <a:avLst/>
           </a:prstGeom>
           <a:solidFill>
-            <a:srgbClr val="FFFFFF"/>
+            <a:srgbClr val="F4F4F4"/>
           </a:solidFill>
           <a:ln>
             <a:noFill/>
@@ -6610,7 +6610,7 @@
             <a:avLst/>
           </a:prstGeom>
           <a:solidFill>
-            <a:srgbClr val="FFE0D0"/>
+            <a:srgbClr val="F9ECE6"/>
           </a:solidFill>
           <a:ln>
             <a:noFill/>
@@ -6625,7 +6625,7 @@
             <a:r>
               <a:rPr sz="1300" b="1">
                 <a:solidFill>
-                  <a:srgbClr val="F06142"/>
+                  <a:srgbClr val="333333"/>
                 </a:solidFill>
                 <a:latin typeface="Yu Gothic"/>
               </a:rPr>
@@ -6649,7 +6649,7 @@
             <a:avLst/>
           </a:prstGeom>
           <a:solidFill>
-            <a:srgbClr val="FFFFFF"/>
+            <a:srgbClr val="F4F4F4"/>
           </a:solidFill>
           <a:ln>
             <a:noFill/>
@@ -6688,7 +6688,7 @@
             <a:avLst/>
           </a:prstGeom>
           <a:solidFill>
-            <a:srgbClr val="FFFFFF"/>
+            <a:srgbClr val="F4F4F4"/>
           </a:solidFill>
           <a:ln>
             <a:noFill/>
@@ -6727,7 +6727,7 @@
             <a:avLst/>
           </a:prstGeom>
           <a:solidFill>
-            <a:srgbClr val="FFE0D0"/>
+            <a:srgbClr val="F9ECE6"/>
           </a:solidFill>
           <a:ln>
             <a:noFill/>
@@ -6742,7 +6742,7 @@
             <a:r>
               <a:rPr sz="1300" b="1">
                 <a:solidFill>
-                  <a:srgbClr val="F06142"/>
+                  <a:srgbClr val="333333"/>
                 </a:solidFill>
                 <a:latin typeface="Yu Gothic"/>
               </a:rPr>
@@ -6766,7 +6766,7 @@
             <a:avLst/>
           </a:prstGeom>
           <a:solidFill>
-            <a:srgbClr val="FFFFFF"/>
+            <a:srgbClr val="F4F4F4"/>
           </a:solidFill>
           <a:ln>
             <a:noFill/>
@@ -6805,7 +6805,7 @@
             <a:avLst/>
           </a:prstGeom>
           <a:solidFill>
-            <a:srgbClr val="FFFFFF"/>
+            <a:srgbClr val="F4F4F4"/>
           </a:solidFill>
           <a:ln>
             <a:noFill/>
@@ -6844,7 +6844,7 @@
             <a:avLst/>
           </a:prstGeom>
           <a:solidFill>
-            <a:srgbClr val="FFE0D0"/>
+            <a:srgbClr val="F9ECE6"/>
           </a:solidFill>
           <a:ln>
             <a:noFill/>
@@ -6859,7 +6859,7 @@
             <a:r>
               <a:rPr sz="1300" b="1">
                 <a:solidFill>
-                  <a:srgbClr val="F06142"/>
+                  <a:srgbClr val="333333"/>
                 </a:solidFill>
                 <a:latin typeface="Yu Gothic"/>
               </a:rPr>
@@ -6883,7 +6883,7 @@
             <a:avLst/>
           </a:prstGeom>
           <a:solidFill>
-            <a:srgbClr val="FFFFFF"/>
+            <a:srgbClr val="F4F4F4"/>
           </a:solidFill>
           <a:ln>
             <a:noFill/>
@@ -6922,7 +6922,7 @@
             <a:avLst/>
           </a:prstGeom>
           <a:solidFill>
-            <a:srgbClr val="FFFFFF"/>
+            <a:srgbClr val="F4F4F4"/>
           </a:solidFill>
           <a:ln>
             <a:noFill/>
@@ -6961,7 +6961,7 @@
             <a:avLst/>
           </a:prstGeom>
           <a:solidFill>
-            <a:srgbClr val="FFE0D0"/>
+            <a:srgbClr val="F9ECE6"/>
           </a:solidFill>
           <a:ln>
             <a:noFill/>
@@ -6976,7 +6976,7 @@
             <a:r>
               <a:rPr sz="1300" b="1">
                 <a:solidFill>
-                  <a:srgbClr val="F06142"/>
+                  <a:srgbClr val="333333"/>
                 </a:solidFill>
                 <a:latin typeface="Yu Gothic"/>
               </a:rPr>
@@ -7000,7 +7000,7 @@
             <a:avLst/>
           </a:prstGeom>
           <a:solidFill>
-            <a:srgbClr val="FFFFFF"/>
+            <a:srgbClr val="F4F4F4"/>
           </a:solidFill>
           <a:ln>
             <a:noFill/>
@@ -7039,7 +7039,7 @@
             <a:avLst/>
           </a:prstGeom>
           <a:solidFill>
-            <a:srgbClr val="FFFFFF"/>
+            <a:srgbClr val="F4F4F4"/>
           </a:solidFill>
           <a:ln>
             <a:noFill/>
@@ -7078,7 +7078,7 @@
             <a:avLst/>
           </a:prstGeom>
           <a:solidFill>
-            <a:srgbClr val="FFE0D0"/>
+            <a:srgbClr val="F9ECE6"/>
           </a:solidFill>
           <a:ln>
             <a:noFill/>
@@ -7093,7 +7093,7 @@
             <a:r>
               <a:rPr sz="1300" b="1">
                 <a:solidFill>
-                  <a:srgbClr val="F06142"/>
+                  <a:srgbClr val="333333"/>
                 </a:solidFill>
                 <a:latin typeface="Yu Gothic"/>
               </a:rPr>
@@ -7117,7 +7117,7 @@
             <a:avLst/>
           </a:prstGeom>
           <a:solidFill>
-            <a:srgbClr val="FFFFFF"/>
+            <a:srgbClr val="F4F4F4"/>
           </a:solidFill>
           <a:ln>
             <a:noFill/>
@@ -7156,7 +7156,7 @@
             <a:avLst/>
           </a:prstGeom>
           <a:solidFill>
-            <a:srgbClr val="FFFFFF"/>
+            <a:srgbClr val="F4F4F4"/>
           </a:solidFill>
           <a:ln>
             <a:noFill/>
@@ -7195,7 +7195,7 @@
             <a:avLst/>
           </a:prstGeom>
           <a:solidFill>
-            <a:srgbClr val="FFE0D0"/>
+            <a:srgbClr val="F9ECE6"/>
           </a:solidFill>
           <a:ln>
             <a:noFill/>
@@ -7210,7 +7210,7 @@
             <a:r>
               <a:rPr sz="1300" b="1">
                 <a:solidFill>
-                  <a:srgbClr val="F06142"/>
+                  <a:srgbClr val="333333"/>
                 </a:solidFill>
                 <a:latin typeface="Yu Gothic"/>
               </a:rPr>
@@ -7234,7 +7234,7 @@
             <a:avLst/>
           </a:prstGeom>
           <a:solidFill>
-            <a:srgbClr val="FFFFFF"/>
+            <a:srgbClr val="F4F4F4"/>
           </a:solidFill>
           <a:ln>
             <a:noFill/>
@@ -7273,7 +7273,7 @@
             <a:avLst/>
           </a:prstGeom>
           <a:solidFill>
-            <a:srgbClr val="FFFFFF"/>
+            <a:srgbClr val="F4F4F4"/>
           </a:solidFill>
           <a:ln>
             <a:noFill/>
@@ -7323,7 +7323,7 @@
             <a:r>
               <a:rPr sz="1400" b="1">
                 <a:solidFill>
-                  <a:srgbClr val="F06142"/>
+                  <a:srgbClr val="333333"/>
                 </a:solidFill>
                 <a:latin typeface="Yu Gothic"/>
               </a:rPr>
@@ -7346,7 +7346,7 @@
     <p:bg>
       <p:bgPr>
         <a:solidFill>
-          <a:srgbClr val="FFEEE4"/>
+          <a:srgbClr val="FFFFFF"/>
         </a:solidFill>
         <a:effectLst/>
       </p:bgPr>
@@ -7366,8 +7366,8 @@
         </p:nvSpPr>
         <p:spPr>
           <a:xfrm>
-            <a:off x="0" y="6675120"/>
-            <a:ext cx="12191695" cy="182880"/>
+            <a:off x="0" y="6766560"/>
+            <a:ext cx="12191695" cy="91440"/>
           </a:xfrm>
           <a:prstGeom prst="rect">
             <a:avLst/>
@@ -7453,7 +7453,7 @@
             <a:r>
               <a:rPr sz="2000" b="1">
                 <a:solidFill>
-                  <a:srgbClr val="F06142"/>
+                  <a:srgbClr val="333333"/>
                 </a:solidFill>
                 <a:latin typeface="Yu Gothic"/>
               </a:rPr>
@@ -7512,7 +7512,7 @@
             <a:avLst/>
           </a:prstGeom>
           <a:solidFill>
-            <a:srgbClr val="F06142"/>
+            <a:srgbClr val="333333"/>
           </a:solidFill>
           <a:ln>
             <a:noFill/>
@@ -7551,7 +7551,7 @@
             <a:avLst/>
           </a:prstGeom>
           <a:solidFill>
-            <a:srgbClr val="F06142"/>
+            <a:srgbClr val="333333"/>
           </a:solidFill>
           <a:ln>
             <a:noFill/>
@@ -7590,7 +7590,7 @@
             <a:avLst/>
           </a:prstGeom>
           <a:solidFill>
-            <a:srgbClr val="F06142"/>
+            <a:srgbClr val="333333"/>
           </a:solidFill>
           <a:ln>
             <a:noFill/>
@@ -7629,7 +7629,7 @@
             <a:avLst/>
           </a:prstGeom>
           <a:solidFill>
-            <a:srgbClr val="FFE0D0"/>
+            <a:srgbClr val="F9ECE6"/>
           </a:solidFill>
           <a:ln>
             <a:noFill/>
@@ -7644,7 +7644,7 @@
             <a:r>
               <a:rPr sz="1300" b="1">
                 <a:solidFill>
-                  <a:srgbClr val="F06142"/>
+                  <a:srgbClr val="333333"/>
                 </a:solidFill>
                 <a:latin typeface="Yu Gothic"/>
               </a:rPr>
@@ -7668,7 +7668,7 @@
             <a:avLst/>
           </a:prstGeom>
           <a:solidFill>
-            <a:srgbClr val="FFFFFF"/>
+            <a:srgbClr val="F4F4F4"/>
           </a:solidFill>
           <a:ln>
             <a:noFill/>
@@ -7707,7 +7707,7 @@
             <a:avLst/>
           </a:prstGeom>
           <a:solidFill>
-            <a:srgbClr val="FFFFFF"/>
+            <a:srgbClr val="F4F4F4"/>
           </a:solidFill>
           <a:ln>
             <a:noFill/>
@@ -7746,7 +7746,7 @@
             <a:avLst/>
           </a:prstGeom>
           <a:solidFill>
-            <a:srgbClr val="FFE0D0"/>
+            <a:srgbClr val="F9ECE6"/>
           </a:solidFill>
           <a:ln>
             <a:noFill/>
@@ -7761,7 +7761,7 @@
             <a:r>
               <a:rPr sz="1300" b="1">
                 <a:solidFill>
-                  <a:srgbClr val="F06142"/>
+                  <a:srgbClr val="333333"/>
                 </a:solidFill>
                 <a:latin typeface="Yu Gothic"/>
               </a:rPr>
@@ -7785,7 +7785,7 @@
             <a:avLst/>
           </a:prstGeom>
           <a:solidFill>
-            <a:srgbClr val="FFFFFF"/>
+            <a:srgbClr val="F4F4F4"/>
           </a:solidFill>
           <a:ln>
             <a:noFill/>
@@ -7824,7 +7824,7 @@
             <a:avLst/>
           </a:prstGeom>
           <a:solidFill>
-            <a:srgbClr val="FFFFFF"/>
+            <a:srgbClr val="F4F4F4"/>
           </a:solidFill>
           <a:ln>
             <a:noFill/>
@@ -7863,7 +7863,7 @@
             <a:avLst/>
           </a:prstGeom>
           <a:solidFill>
-            <a:srgbClr val="FFE0D0"/>
+            <a:srgbClr val="F9ECE6"/>
           </a:solidFill>
           <a:ln>
             <a:noFill/>
@@ -7878,7 +7878,7 @@
             <a:r>
               <a:rPr sz="1300" b="1">
                 <a:solidFill>
-                  <a:srgbClr val="F06142"/>
+                  <a:srgbClr val="333333"/>
                 </a:solidFill>
                 <a:latin typeface="Yu Gothic"/>
               </a:rPr>
@@ -7902,7 +7902,7 @@
             <a:avLst/>
           </a:prstGeom>
           <a:solidFill>
-            <a:srgbClr val="FFFFFF"/>
+            <a:srgbClr val="F4F4F4"/>
           </a:solidFill>
           <a:ln>
             <a:noFill/>
@@ -7941,7 +7941,7 @@
             <a:avLst/>
           </a:prstGeom>
           <a:solidFill>
-            <a:srgbClr val="FFFFFF"/>
+            <a:srgbClr val="F4F4F4"/>
           </a:solidFill>
           <a:ln>
             <a:noFill/>
@@ -7980,7 +7980,7 @@
             <a:avLst/>
           </a:prstGeom>
           <a:solidFill>
-            <a:srgbClr val="FFE0D0"/>
+            <a:srgbClr val="F9ECE6"/>
           </a:solidFill>
           <a:ln>
             <a:noFill/>
@@ -7995,7 +7995,7 @@
             <a:r>
               <a:rPr sz="1300" b="1">
                 <a:solidFill>
-                  <a:srgbClr val="F06142"/>
+                  <a:srgbClr val="333333"/>
                 </a:solidFill>
                 <a:latin typeface="Yu Gothic"/>
               </a:rPr>
@@ -8019,7 +8019,7 @@
             <a:avLst/>
           </a:prstGeom>
           <a:solidFill>
-            <a:srgbClr val="FFFFFF"/>
+            <a:srgbClr val="F4F4F4"/>
           </a:solidFill>
           <a:ln>
             <a:noFill/>
@@ -8058,7 +8058,7 @@
             <a:avLst/>
           </a:prstGeom>
           <a:solidFill>
-            <a:srgbClr val="FFFFFF"/>
+            <a:srgbClr val="F4F4F4"/>
           </a:solidFill>
           <a:ln>
             <a:noFill/>
@@ -8097,7 +8097,7 @@
             <a:avLst/>
           </a:prstGeom>
           <a:solidFill>
-            <a:srgbClr val="FFE0D0"/>
+            <a:srgbClr val="F9ECE6"/>
           </a:solidFill>
           <a:ln>
             <a:noFill/>
@@ -8112,7 +8112,7 @@
             <a:r>
               <a:rPr sz="1300" b="1">
                 <a:solidFill>
-                  <a:srgbClr val="F06142"/>
+                  <a:srgbClr val="333333"/>
                 </a:solidFill>
                 <a:latin typeface="Yu Gothic"/>
               </a:rPr>
@@ -8136,7 +8136,7 @@
             <a:avLst/>
           </a:prstGeom>
           <a:solidFill>
-            <a:srgbClr val="FFFFFF"/>
+            <a:srgbClr val="F4F4F4"/>
           </a:solidFill>
           <a:ln>
             <a:noFill/>
@@ -8175,7 +8175,7 @@
             <a:avLst/>
           </a:prstGeom>
           <a:solidFill>
-            <a:srgbClr val="FFFFFF"/>
+            <a:srgbClr val="F4F4F4"/>
           </a:solidFill>
           <a:ln>
             <a:noFill/>
@@ -8214,7 +8214,7 @@
             <a:avLst/>
           </a:prstGeom>
           <a:solidFill>
-            <a:srgbClr val="FFE0D0"/>
+            <a:srgbClr val="F9ECE6"/>
           </a:solidFill>
           <a:ln>
             <a:noFill/>
@@ -8229,7 +8229,7 @@
             <a:r>
               <a:rPr sz="1300" b="1">
                 <a:solidFill>
-                  <a:srgbClr val="F06142"/>
+                  <a:srgbClr val="333333"/>
                 </a:solidFill>
                 <a:latin typeface="Yu Gothic"/>
               </a:rPr>
@@ -8253,7 +8253,7 @@
             <a:avLst/>
           </a:prstGeom>
           <a:solidFill>
-            <a:srgbClr val="FFFFFF"/>
+            <a:srgbClr val="F4F4F4"/>
           </a:solidFill>
           <a:ln>
             <a:noFill/>
@@ -8292,7 +8292,7 @@
             <a:avLst/>
           </a:prstGeom>
           <a:solidFill>
-            <a:srgbClr val="FFFFFF"/>
+            <a:srgbClr val="F4F4F4"/>
           </a:solidFill>
           <a:ln>
             <a:noFill/>
@@ -8331,7 +8331,7 @@
             <a:avLst/>
           </a:prstGeom>
           <a:solidFill>
-            <a:srgbClr val="FFE0D0"/>
+            <a:srgbClr val="F9ECE6"/>
           </a:solidFill>
           <a:ln>
             <a:noFill/>
@@ -8346,7 +8346,7 @@
             <a:r>
               <a:rPr sz="1500" b="1">
                 <a:solidFill>
-                  <a:srgbClr val="F06142"/>
+                  <a:srgbClr val="333333"/>
                 </a:solidFill>
                 <a:latin typeface="Yu Gothic"/>
               </a:rPr>
@@ -8385,7 +8385,7 @@
     <p:bg>
       <p:bgPr>
         <a:solidFill>
-          <a:srgbClr val="FFEEE4"/>
+          <a:srgbClr val="FFFFFF"/>
         </a:solidFill>
         <a:effectLst/>
       </p:bgPr>
@@ -8405,8 +8405,8 @@
         </p:nvSpPr>
         <p:spPr>
           <a:xfrm>
-            <a:off x="0" y="6675120"/>
-            <a:ext cx="12191695" cy="182880"/>
+            <a:off x="0" y="6766560"/>
+            <a:ext cx="12191695" cy="91440"/>
           </a:xfrm>
           <a:prstGeom prst="rect">
             <a:avLst/>
@@ -8492,7 +8492,7 @@
             <a:r>
               <a:rPr sz="2000" b="1">
                 <a:solidFill>
-                  <a:srgbClr val="F06142"/>
+                  <a:srgbClr val="333333"/>
                 </a:solidFill>
                 <a:latin typeface="Yu Gothic"/>
               </a:rPr>
@@ -8562,7 +8562,7 @@
             <a:r>
               <a:rPr sz="1600" b="1">
                 <a:solidFill>
-                  <a:srgbClr val="F06142"/>
+                  <a:srgbClr val="333333"/>
                 </a:solidFill>
                 <a:latin typeface="Yu Gothic"/>
               </a:rPr>
@@ -8586,7 +8586,7 @@
             <a:avLst/>
           </a:prstGeom>
           <a:solidFill>
-            <a:srgbClr val="F06142"/>
+            <a:srgbClr val="333333"/>
           </a:solidFill>
           <a:ln>
             <a:noFill/>
@@ -8625,7 +8625,7 @@
             <a:avLst/>
           </a:prstGeom>
           <a:solidFill>
-            <a:srgbClr val="F06142"/>
+            <a:srgbClr val="333333"/>
           </a:solidFill>
           <a:ln>
             <a:noFill/>
@@ -8664,7 +8664,7 @@
             <a:avLst/>
           </a:prstGeom>
           <a:solidFill>
-            <a:srgbClr val="F06142"/>
+            <a:srgbClr val="333333"/>
           </a:solidFill>
           <a:ln>
             <a:noFill/>
@@ -8703,7 +8703,7 @@
             <a:avLst/>
           </a:prstGeom>
           <a:solidFill>
-            <a:srgbClr val="FFE0D0"/>
+            <a:srgbClr val="F9ECE6"/>
           </a:solidFill>
           <a:ln>
             <a:noFill/>
@@ -8718,7 +8718,7 @@
             <a:r>
               <a:rPr sz="1400" b="1">
                 <a:solidFill>
-                  <a:srgbClr val="F06142"/>
+                  <a:srgbClr val="333333"/>
                 </a:solidFill>
                 <a:latin typeface="Yu Gothic"/>
               </a:rPr>
@@ -8742,7 +8742,7 @@
             <a:avLst/>
           </a:prstGeom>
           <a:solidFill>
-            <a:srgbClr val="FFFFFF"/>
+            <a:srgbClr val="F4F4F4"/>
           </a:solidFill>
           <a:ln>
             <a:noFill/>
@@ -8781,7 +8781,7 @@
             <a:avLst/>
           </a:prstGeom>
           <a:solidFill>
-            <a:srgbClr val="FFFFFF"/>
+            <a:srgbClr val="F4F4F4"/>
           </a:solidFill>
           <a:ln>
             <a:noFill/>
@@ -8820,7 +8820,7 @@
             <a:avLst/>
           </a:prstGeom>
           <a:solidFill>
-            <a:srgbClr val="FFE0D0"/>
+            <a:srgbClr val="F9ECE6"/>
           </a:solidFill>
           <a:ln>
             <a:noFill/>
@@ -8835,7 +8835,7 @@
             <a:r>
               <a:rPr sz="1400" b="1">
                 <a:solidFill>
-                  <a:srgbClr val="F06142"/>
+                  <a:srgbClr val="333333"/>
                 </a:solidFill>
                 <a:latin typeface="Yu Gothic"/>
               </a:rPr>
@@ -8859,7 +8859,7 @@
             <a:avLst/>
           </a:prstGeom>
           <a:solidFill>
-            <a:srgbClr val="FFFFFF"/>
+            <a:srgbClr val="F4F4F4"/>
           </a:solidFill>
           <a:ln>
             <a:noFill/>
@@ -8898,7 +8898,7 @@
             <a:avLst/>
           </a:prstGeom>
           <a:solidFill>
-            <a:srgbClr val="FFFFFF"/>
+            <a:srgbClr val="F4F4F4"/>
           </a:solidFill>
           <a:ln>
             <a:noFill/>
@@ -8937,7 +8937,7 @@
             <a:avLst/>
           </a:prstGeom>
           <a:solidFill>
-            <a:srgbClr val="FFE0D0"/>
+            <a:srgbClr val="F9ECE6"/>
           </a:solidFill>
           <a:ln>
             <a:noFill/>
@@ -8952,7 +8952,7 @@
             <a:r>
               <a:rPr sz="1400" b="1">
                 <a:solidFill>
-                  <a:srgbClr val="F06142"/>
+                  <a:srgbClr val="333333"/>
                 </a:solidFill>
                 <a:latin typeface="Yu Gothic"/>
               </a:rPr>
@@ -8976,7 +8976,7 @@
             <a:avLst/>
           </a:prstGeom>
           <a:solidFill>
-            <a:srgbClr val="FFFFFF"/>
+            <a:srgbClr val="F4F4F4"/>
           </a:solidFill>
           <a:ln>
             <a:noFill/>
@@ -9015,7 +9015,7 @@
             <a:avLst/>
           </a:prstGeom>
           <a:solidFill>
-            <a:srgbClr val="FFFFFF"/>
+            <a:srgbClr val="F4F4F4"/>
           </a:solidFill>
           <a:ln>
             <a:noFill/>
@@ -9054,7 +9054,7 @@
             <a:avLst/>
           </a:prstGeom>
           <a:solidFill>
-            <a:srgbClr val="FFE0D0"/>
+            <a:srgbClr val="F9ECE6"/>
           </a:solidFill>
           <a:ln>
             <a:noFill/>
@@ -9069,7 +9069,7 @@
             <a:r>
               <a:rPr sz="1400" b="1">
                 <a:solidFill>
-                  <a:srgbClr val="F06142"/>
+                  <a:srgbClr val="333333"/>
                 </a:solidFill>
                 <a:latin typeface="Yu Gothic"/>
               </a:rPr>
@@ -9093,7 +9093,7 @@
             <a:avLst/>
           </a:prstGeom>
           <a:solidFill>
-            <a:srgbClr val="FFFFFF"/>
+            <a:srgbClr val="F4F4F4"/>
           </a:solidFill>
           <a:ln>
             <a:noFill/>
@@ -9132,7 +9132,7 @@
             <a:avLst/>
           </a:prstGeom>
           <a:solidFill>
-            <a:srgbClr val="FFFFFF"/>
+            <a:srgbClr val="F4F4F4"/>
           </a:solidFill>
           <a:ln>
             <a:noFill/>
@@ -9171,7 +9171,7 @@
             <a:avLst/>
           </a:prstGeom>
           <a:solidFill>
-            <a:srgbClr val="FFE0D0"/>
+            <a:srgbClr val="F9ECE6"/>
           </a:solidFill>
           <a:ln>
             <a:noFill/>
@@ -9212,7 +9212,7 @@
             <a:r>
               <a:rPr sz="1600" b="1">
                 <a:solidFill>
-                  <a:srgbClr val="F06142"/>
+                  <a:srgbClr val="333333"/>
                 </a:solidFill>
                 <a:latin typeface="Yu Gothic"/>
               </a:rPr>
@@ -9290,7 +9290,7 @@
     <p:bg>
       <p:bgPr>
         <a:solidFill>
-          <a:srgbClr val="FFEEE4"/>
+          <a:srgbClr val="FFFFFF"/>
         </a:solidFill>
         <a:effectLst/>
       </p:bgPr>
@@ -9310,8 +9310,8 @@
         </p:nvSpPr>
         <p:spPr>
           <a:xfrm>
-            <a:off x="0" y="6675120"/>
-            <a:ext cx="12191695" cy="182880"/>
+            <a:off x="0" y="6766560"/>
+            <a:ext cx="12191695" cy="91440"/>
           </a:xfrm>
           <a:prstGeom prst="rect">
             <a:avLst/>
@@ -9397,7 +9397,7 @@
             <a:r>
               <a:rPr sz="2000" b="1">
                 <a:solidFill>
-                  <a:srgbClr val="F06142"/>
+                  <a:srgbClr val="333333"/>
                 </a:solidFill>
                 <a:latin typeface="Yu Gothic"/>
               </a:rPr>
@@ -9456,7 +9456,7 @@
             <a:avLst/>
           </a:prstGeom>
           <a:solidFill>
-            <a:srgbClr val="F06142"/>
+            <a:srgbClr val="333333"/>
           </a:solidFill>
           <a:ln>
             <a:noFill/>
@@ -9495,7 +9495,7 @@
             <a:avLst/>
           </a:prstGeom>
           <a:solidFill>
-            <a:srgbClr val="F06142"/>
+            <a:srgbClr val="333333"/>
           </a:solidFill>
           <a:ln>
             <a:noFill/>
@@ -9534,7 +9534,7 @@
             <a:avLst/>
           </a:prstGeom>
           <a:solidFill>
-            <a:srgbClr val="F06142"/>
+            <a:srgbClr val="333333"/>
           </a:solidFill>
           <a:ln>
             <a:noFill/>
@@ -9573,7 +9573,7 @@
             <a:avLst/>
           </a:prstGeom>
           <a:solidFill>
-            <a:srgbClr val="FFE0D0"/>
+            <a:srgbClr val="F9ECE6"/>
           </a:solidFill>
           <a:ln>
             <a:noFill/>
@@ -9588,7 +9588,7 @@
             <a:r>
               <a:rPr sz="1300" b="1">
                 <a:solidFill>
-                  <a:srgbClr val="F06142"/>
+                  <a:srgbClr val="333333"/>
                 </a:solidFill>
                 <a:latin typeface="Yu Gothic"/>
               </a:rPr>
@@ -9612,7 +9612,7 @@
             <a:avLst/>
           </a:prstGeom>
           <a:solidFill>
-            <a:srgbClr val="FFFFFF"/>
+            <a:srgbClr val="F4F4F4"/>
           </a:solidFill>
           <a:ln>
             <a:noFill/>
@@ -9651,7 +9651,7 @@
             <a:avLst/>
           </a:prstGeom>
           <a:solidFill>
-            <a:srgbClr val="FFFFFF"/>
+            <a:srgbClr val="F4F4F4"/>
           </a:solidFill>
           <a:ln>
             <a:noFill/>
@@ -9690,7 +9690,7 @@
             <a:avLst/>
           </a:prstGeom>
           <a:solidFill>
-            <a:srgbClr val="FFE0D0"/>
+            <a:srgbClr val="F9ECE6"/>
           </a:solidFill>
           <a:ln>
             <a:noFill/>
@@ -9705,7 +9705,7 @@
             <a:r>
               <a:rPr sz="1300" b="1">
                 <a:solidFill>
-                  <a:srgbClr val="F06142"/>
+                  <a:srgbClr val="333333"/>
                 </a:solidFill>
                 <a:latin typeface="Yu Gothic"/>
               </a:rPr>
@@ -9729,7 +9729,7 @@
             <a:avLst/>
           </a:prstGeom>
           <a:solidFill>
-            <a:srgbClr val="FFFFFF"/>
+            <a:srgbClr val="F4F4F4"/>
           </a:solidFill>
           <a:ln>
             <a:noFill/>
@@ -9768,7 +9768,7 @@
             <a:avLst/>
           </a:prstGeom>
           <a:solidFill>
-            <a:srgbClr val="FFFFFF"/>
+            <a:srgbClr val="F4F4F4"/>
           </a:solidFill>
           <a:ln>
             <a:noFill/>
@@ -9807,7 +9807,7 @@
             <a:avLst/>
           </a:prstGeom>
           <a:solidFill>
-            <a:srgbClr val="FFE0D0"/>
+            <a:srgbClr val="F9ECE6"/>
           </a:solidFill>
           <a:ln>
             <a:noFill/>
@@ -9822,7 +9822,7 @@
             <a:r>
               <a:rPr sz="1300" b="1">
                 <a:solidFill>
-                  <a:srgbClr val="F06142"/>
+                  <a:srgbClr val="333333"/>
                 </a:solidFill>
                 <a:latin typeface="Yu Gothic"/>
               </a:rPr>
@@ -9846,7 +9846,7 @@
             <a:avLst/>
           </a:prstGeom>
           <a:solidFill>
-            <a:srgbClr val="FFFFFF"/>
+            <a:srgbClr val="F4F4F4"/>
           </a:solidFill>
           <a:ln>
             <a:noFill/>
@@ -9885,7 +9885,7 @@
             <a:avLst/>
           </a:prstGeom>
           <a:solidFill>
-            <a:srgbClr val="FFFFFF"/>
+            <a:srgbClr val="F4F4F4"/>
           </a:solidFill>
           <a:ln>
             <a:noFill/>
@@ -9924,7 +9924,7 @@
             <a:avLst/>
           </a:prstGeom>
           <a:solidFill>
-            <a:srgbClr val="FFE0D0"/>
+            <a:srgbClr val="F9ECE6"/>
           </a:solidFill>
           <a:ln>
             <a:noFill/>
@@ -9939,7 +9939,7 @@
             <a:r>
               <a:rPr sz="1300" b="1">
                 <a:solidFill>
-                  <a:srgbClr val="F06142"/>
+                  <a:srgbClr val="333333"/>
                 </a:solidFill>
                 <a:latin typeface="Yu Gothic"/>
               </a:rPr>
@@ -9963,7 +9963,7 @@
             <a:avLst/>
           </a:prstGeom>
           <a:solidFill>
-            <a:srgbClr val="FFFFFF"/>
+            <a:srgbClr val="F4F4F4"/>
           </a:solidFill>
           <a:ln>
             <a:noFill/>
@@ -10002,7 +10002,7 @@
             <a:avLst/>
           </a:prstGeom>
           <a:solidFill>
-            <a:srgbClr val="FFFFFF"/>
+            <a:srgbClr val="F4F4F4"/>
           </a:solidFill>
           <a:ln>
             <a:noFill/>
@@ -10041,7 +10041,7 @@
             <a:avLst/>
           </a:prstGeom>
           <a:solidFill>
-            <a:srgbClr val="FFE0D0"/>
+            <a:srgbClr val="F9ECE6"/>
           </a:solidFill>
           <a:ln>
             <a:noFill/>
@@ -10056,7 +10056,7 @@
             <a:r>
               <a:rPr sz="1300" b="1">
                 <a:solidFill>
-                  <a:srgbClr val="F06142"/>
+                  <a:srgbClr val="333333"/>
                 </a:solidFill>
                 <a:latin typeface="Yu Gothic"/>
               </a:rPr>
@@ -10080,7 +10080,7 @@
             <a:avLst/>
           </a:prstGeom>
           <a:solidFill>
-            <a:srgbClr val="FFFFFF"/>
+            <a:srgbClr val="F4F4F4"/>
           </a:solidFill>
           <a:ln>
             <a:noFill/>
@@ -10119,7 +10119,7 @@
             <a:avLst/>
           </a:prstGeom>
           <a:solidFill>
-            <a:srgbClr val="FFFFFF"/>
+            <a:srgbClr val="F4F4F4"/>
           </a:solidFill>
           <a:ln>
             <a:noFill/>
@@ -10158,7 +10158,7 @@
             <a:avLst/>
           </a:prstGeom>
           <a:solidFill>
-            <a:srgbClr val="FFE0D0"/>
+            <a:srgbClr val="F9ECE6"/>
           </a:solidFill>
           <a:ln>
             <a:noFill/>
@@ -10173,7 +10173,7 @@
             <a:r>
               <a:rPr sz="1300" b="1">
                 <a:solidFill>
-                  <a:srgbClr val="F06142"/>
+                  <a:srgbClr val="333333"/>
                 </a:solidFill>
                 <a:latin typeface="Yu Gothic"/>
               </a:rPr>
@@ -10197,7 +10197,7 @@
             <a:avLst/>
           </a:prstGeom>
           <a:solidFill>
-            <a:srgbClr val="FFFFFF"/>
+            <a:srgbClr val="F4F4F4"/>
           </a:solidFill>
           <a:ln>
             <a:noFill/>
@@ -10236,7 +10236,7 @@
             <a:avLst/>
           </a:prstGeom>
           <a:solidFill>
-            <a:srgbClr val="FFFFFF"/>
+            <a:srgbClr val="F4F4F4"/>
           </a:solidFill>
           <a:ln>
             <a:noFill/>
@@ -10275,7 +10275,7 @@
             <a:avLst/>
           </a:prstGeom>
           <a:solidFill>
-            <a:srgbClr val="FFE0D0"/>
+            <a:srgbClr val="F9ECE6"/>
           </a:solidFill>
           <a:ln>
             <a:noFill/>
@@ -10290,7 +10290,7 @@
             <a:r>
               <a:rPr sz="1300" b="1">
                 <a:solidFill>
-                  <a:srgbClr val="F06142"/>
+                  <a:srgbClr val="333333"/>
                 </a:solidFill>
                 <a:latin typeface="Yu Gothic"/>
               </a:rPr>
@@ -10314,7 +10314,7 @@
             <a:avLst/>
           </a:prstGeom>
           <a:solidFill>
-            <a:srgbClr val="FFFFFF"/>
+            <a:srgbClr val="F4F4F4"/>
           </a:solidFill>
           <a:ln>
             <a:noFill/>
@@ -10353,7 +10353,7 @@
             <a:avLst/>
           </a:prstGeom>
           <a:solidFill>
-            <a:srgbClr val="FFFFFF"/>
+            <a:srgbClr val="F4F4F4"/>
           </a:solidFill>
           <a:ln>
             <a:noFill/>
@@ -10392,7 +10392,7 @@
             <a:avLst/>
           </a:prstGeom>
           <a:solidFill>
-            <a:srgbClr val="FFE0D0"/>
+            <a:srgbClr val="F9ECE6"/>
           </a:solidFill>
           <a:ln>
             <a:noFill/>
@@ -10407,7 +10407,7 @@
             <a:r>
               <a:rPr sz="1300" b="1">
                 <a:solidFill>
-                  <a:srgbClr val="F06142"/>
+                  <a:srgbClr val="333333"/>
                 </a:solidFill>
                 <a:latin typeface="Yu Gothic"/>
               </a:rPr>
@@ -10431,7 +10431,7 @@
             <a:avLst/>
           </a:prstGeom>
           <a:solidFill>
-            <a:srgbClr val="FFFFFF"/>
+            <a:srgbClr val="F4F4F4"/>
           </a:solidFill>
           <a:ln>
             <a:noFill/>
@@ -10470,7 +10470,7 @@
             <a:avLst/>
           </a:prstGeom>
           <a:solidFill>
-            <a:srgbClr val="FFFFFF"/>
+            <a:srgbClr val="F4F4F4"/>
           </a:solidFill>
           <a:ln>
             <a:noFill/>
@@ -10509,7 +10509,7 @@
             <a:avLst/>
           </a:prstGeom>
           <a:solidFill>
-            <a:srgbClr val="FFE0D0"/>
+            <a:srgbClr val="F9ECE6"/>
           </a:solidFill>
           <a:ln>
             <a:noFill/>
@@ -10524,7 +10524,7 @@
             <a:r>
               <a:rPr sz="1300" b="1">
                 <a:solidFill>
-                  <a:srgbClr val="F06142"/>
+                  <a:srgbClr val="333333"/>
                 </a:solidFill>
                 <a:latin typeface="Yu Gothic"/>
               </a:rPr>
@@ -10548,7 +10548,7 @@
             <a:avLst/>
           </a:prstGeom>
           <a:solidFill>
-            <a:srgbClr val="FFFFFF"/>
+            <a:srgbClr val="F4F4F4"/>
           </a:solidFill>
           <a:ln>
             <a:noFill/>
@@ -10587,7 +10587,7 @@
             <a:avLst/>
           </a:prstGeom>
           <a:solidFill>
-            <a:srgbClr val="FFFFFF"/>
+            <a:srgbClr val="F4F4F4"/>
           </a:solidFill>
           <a:ln>
             <a:noFill/>
@@ -10626,7 +10626,7 @@
             <a:avLst/>
           </a:prstGeom>
           <a:solidFill>
-            <a:srgbClr val="FFE0D0"/>
+            <a:srgbClr val="F9ECE6"/>
           </a:solidFill>
           <a:ln>
             <a:noFill/>
@@ -10641,7 +10641,7 @@
             <a:r>
               <a:rPr sz="1300" b="1">
                 <a:solidFill>
-                  <a:srgbClr val="F06142"/>
+                  <a:srgbClr val="333333"/>
                 </a:solidFill>
                 <a:latin typeface="Yu Gothic"/>
               </a:rPr>
@@ -10665,7 +10665,7 @@
             <a:avLst/>
           </a:prstGeom>
           <a:solidFill>
-            <a:srgbClr val="FFFFFF"/>
+            <a:srgbClr val="F4F4F4"/>
           </a:solidFill>
           <a:ln>
             <a:noFill/>
@@ -10704,7 +10704,7 @@
             <a:avLst/>
           </a:prstGeom>
           <a:solidFill>
-            <a:srgbClr val="FFFFFF"/>
+            <a:srgbClr val="F4F4F4"/>
           </a:solidFill>
           <a:ln>
             <a:noFill/>
@@ -10754,7 +10754,7 @@
             <a:r>
               <a:rPr sz="1300" b="1">
                 <a:solidFill>
-                  <a:srgbClr val="F06142"/>
+                  <a:srgbClr val="333333"/>
                 </a:solidFill>
                 <a:latin typeface="Yu Gothic"/>
               </a:rPr>

</xml_diff>